<commit_message>
Finalize S3 data, citation metadata, documentation and figures
</commit_message>
<xml_diff>
--- a/figures/Figure1.pptx
+++ b/figures/Figure1.pptx
@@ -270,7 +270,7 @@
           <a:p>
             <a:fld id="{98D5C8C2-D309-8749-9D88-23815EB2525A}" type="datetimeFigureOut">
               <a:rPr lang="en-US" smtClean="0"/>
-              <a:t>10/8/26</a:t>
+              <a:t>10/9/26</a:t>
             </a:fld>
             <a:endParaRPr lang="en-US"/>
           </a:p>
@@ -468,7 +468,7 @@
           <a:p>
             <a:fld id="{98D5C8C2-D309-8749-9D88-23815EB2525A}" type="datetimeFigureOut">
               <a:rPr lang="en-US" smtClean="0"/>
-              <a:t>10/8/26</a:t>
+              <a:t>10/9/26</a:t>
             </a:fld>
             <a:endParaRPr lang="en-US"/>
           </a:p>
@@ -676,7 +676,7 @@
           <a:p>
             <a:fld id="{98D5C8C2-D309-8749-9D88-23815EB2525A}" type="datetimeFigureOut">
               <a:rPr lang="en-US" smtClean="0"/>
-              <a:t>10/8/26</a:t>
+              <a:t>10/9/26</a:t>
             </a:fld>
             <a:endParaRPr lang="en-US"/>
           </a:p>
@@ -874,7 +874,7 @@
           <a:p>
             <a:fld id="{98D5C8C2-D309-8749-9D88-23815EB2525A}" type="datetimeFigureOut">
               <a:rPr lang="en-US" smtClean="0"/>
-              <a:t>10/8/26</a:t>
+              <a:t>10/9/26</a:t>
             </a:fld>
             <a:endParaRPr lang="en-US"/>
           </a:p>
@@ -1149,7 +1149,7 @@
           <a:p>
             <a:fld id="{98D5C8C2-D309-8749-9D88-23815EB2525A}" type="datetimeFigureOut">
               <a:rPr lang="en-US" smtClean="0"/>
-              <a:t>10/8/26</a:t>
+              <a:t>10/9/26</a:t>
             </a:fld>
             <a:endParaRPr lang="en-US"/>
           </a:p>
@@ -1414,7 +1414,7 @@
           <a:p>
             <a:fld id="{98D5C8C2-D309-8749-9D88-23815EB2525A}" type="datetimeFigureOut">
               <a:rPr lang="en-US" smtClean="0"/>
-              <a:t>10/8/26</a:t>
+              <a:t>10/9/26</a:t>
             </a:fld>
             <a:endParaRPr lang="en-US"/>
           </a:p>
@@ -1826,7 +1826,7 @@
           <a:p>
             <a:fld id="{98D5C8C2-D309-8749-9D88-23815EB2525A}" type="datetimeFigureOut">
               <a:rPr lang="en-US" smtClean="0"/>
-              <a:t>10/8/26</a:t>
+              <a:t>10/9/26</a:t>
             </a:fld>
             <a:endParaRPr lang="en-US"/>
           </a:p>
@@ -1967,7 +1967,7 @@
           <a:p>
             <a:fld id="{98D5C8C2-D309-8749-9D88-23815EB2525A}" type="datetimeFigureOut">
               <a:rPr lang="en-US" smtClean="0"/>
-              <a:t>10/8/26</a:t>
+              <a:t>10/9/26</a:t>
             </a:fld>
             <a:endParaRPr lang="en-US"/>
           </a:p>
@@ -2080,7 +2080,7 @@
           <a:p>
             <a:fld id="{98D5C8C2-D309-8749-9D88-23815EB2525A}" type="datetimeFigureOut">
               <a:rPr lang="en-US" smtClean="0"/>
-              <a:t>10/8/26</a:t>
+              <a:t>10/9/26</a:t>
             </a:fld>
             <a:endParaRPr lang="en-US"/>
           </a:p>
@@ -2391,7 +2391,7 @@
           <a:p>
             <a:fld id="{98D5C8C2-D309-8749-9D88-23815EB2525A}" type="datetimeFigureOut">
               <a:rPr lang="en-US" smtClean="0"/>
-              <a:t>10/8/26</a:t>
+              <a:t>10/9/26</a:t>
             </a:fld>
             <a:endParaRPr lang="en-US"/>
           </a:p>
@@ -2679,7 +2679,7 @@
           <a:p>
             <a:fld id="{98D5C8C2-D309-8749-9D88-23815EB2525A}" type="datetimeFigureOut">
               <a:rPr lang="en-US" smtClean="0"/>
-              <a:t>10/8/26</a:t>
+              <a:t>10/9/26</a:t>
             </a:fld>
             <a:endParaRPr lang="en-US"/>
           </a:p>
@@ -2920,7 +2920,7 @@
           <a:p>
             <a:fld id="{98D5C8C2-D309-8749-9D88-23815EB2525A}" type="datetimeFigureOut">
               <a:rPr lang="en-US" smtClean="0"/>
-              <a:t>10/8/26</a:t>
+              <a:t>10/9/26</a:t>
             </a:fld>
             <a:endParaRPr lang="en-US"/>
           </a:p>
@@ -3704,7 +3704,7 @@
         <p:spPr>
           <a:xfrm>
             <a:off x="4830523" y="689517"/>
-            <a:ext cx="753732" cy="338554"/>
+            <a:ext cx="777777" cy="338554"/>
           </a:xfrm>
           <a:prstGeom prst="rect">
             <a:avLst/>
@@ -3718,12 +3718,16 @@
           <a:lstStyle/>
           <a:p>
             <a:r>
-              <a:rPr lang="en-US" sz="1600" dirty="0">
+              <a:rPr lang="en-US" sz="1600">
                 <a:latin typeface="Arial" panose="020B0604020202020204" pitchFamily="34" charset="0"/>
                 <a:cs typeface="Arial" panose="020B0604020202020204" pitchFamily="34" charset="0"/>
               </a:rPr>
-              <a:t>AM2H</a:t>
-            </a:r>
+              <a:t>AM2M</a:t>
+            </a:r>
+            <a:endParaRPr lang="en-US" sz="1600" dirty="0">
+              <a:latin typeface="Arial" panose="020B0604020202020204" pitchFamily="34" charset="0"/>
+              <a:cs typeface="Arial" panose="020B0604020202020204" pitchFamily="34" charset="0"/>
+            </a:endParaRPr>
           </a:p>
         </p:txBody>
       </p:sp>
@@ -3836,14 +3840,14 @@
                 <a:latin typeface="Times New Roman" panose="02020603050405020304" pitchFamily="18" charset="0"/>
                 <a:cs typeface="Times New Roman" panose="02020603050405020304" pitchFamily="18" charset="0"/>
               </a:rPr>
-              <a:t>F I G U R E 1 </a:t>
+              <a:t>Figure 1. </a:t>
             </a:r>
             <a:r>
               <a:rPr lang="en-US" sz="1200" dirty="0">
                 <a:latin typeface="Times New Roman" panose="02020603050405020304" pitchFamily="18" charset="0"/>
                 <a:cs typeface="Times New Roman" panose="02020603050405020304" pitchFamily="18" charset="0"/>
               </a:rPr>
-              <a:t>Physics-based and diffusion-based design methods converge on a natural H2E4 topology. (a) Experimental structures of LNG (9BK5:A), designed by RFdiffusion against </a:t>
+              <a:t>Three designed proteins and two natural Y-family polymerase little-finger domains share the same H2E4 topology. (a) Experimental structures of LNG (9BK5:A), designed by RFdiffusion against </a:t>
             </a:r>
             <a:r>
               <a:rPr lang="el-GR" sz="1200" dirty="0">

</xml_diff>